<commit_message>
VAURE : présentation sans mention de la formation
Co-Authored-By: Claude Opus 5.5 <noreply@anthropic.com>
Claude-Session: https://claude.ai/code/session_01E27fDM9kXMS7n6PL6YkZM1
</commit_message>
<xml_diff>
--- a/vaure/presentation/VAURE-presentation.pptx
+++ b/vaure/presentation/VAURE-presentation.pptx
@@ -119,39 +119,39 @@
   <p:extLst>
     <p:ext uri="{521415D9-36F7-43E2-AB2F-B90AF26B5E84}">
       <p14:sectionLst xmlns:p14="http://schemas.microsoft.com/office/powerpoint/2010/main">
-        <p14:section name="Ouverture" id="{bb21dd6f-6289-d8a3-aff7-868f80f9c299}">
+        <p14:section name="Ouverture" id="{f0101312-179a-e8b4-21ec-fc2ca3716569}">
           <p14:sldIdLst>
             <p14:sldId id="256"/>
           </p14:sldIdLst>
         </p14:section>
-        <p14:section name="La niche" id="{1ba20956-a4ba-e3b4-2af9-e04a1806c760}">
+        <p14:section name="La niche" id="{d3e225a9-a9d3-7937-434a-54e0680bf8b1}">
           <p14:sldIdLst>
             <p14:sldId id="257"/>
             <p14:sldId id="258"/>
             <p14:sldId id="259"/>
           </p14:sldIdLst>
         </p14:section>
-        <p14:section name="Pourquoi" id="{be337b8f-c270-0db9-4b9d-78840e400a5d}">
+        <p14:section name="Pourquoi" id="{f3e703cd-4957-a006-ce3f-85be0e10b2ca}">
           <p14:sldIdLst>
             <p14:sldId id="260"/>
             <p14:sldId id="261"/>
           </p14:sldIdLst>
         </p14:section>
-        <p14:section name="L'offre" id="{a065c5c9-795e-59b5-5e4a-77a3122cac83}">
+        <p14:section name="L'offre" id="{6ff32227-88cc-2856-8fed-d29f6eb63b90}">
           <p14:sldIdLst>
             <p14:sldId id="262"/>
             <p14:sldId id="263"/>
             <p14:sldId id="264"/>
           </p14:sldIdLst>
         </p14:section>
-        <p14:section name="Vendre" id="{7ebceac3-3976-0559-bea1-fbcd640f874e}">
+        <p14:section name="Vendre" id="{9193049d-0701-0f07-58e6-88f6726fcf43}">
           <p14:sldIdLst>
             <p14:sldId id="265"/>
             <p14:sldId id="266"/>
             <p14:sldId id="267"/>
           </p14:sldIdLst>
         </p14:section>
-        <p14:section name="Clôture" id="{90d88650-7db7-d286-446b-c51ae65314c1}">
+        <p14:section name="Clôture" id="{450d8a6b-680a-a7d9-abaa-dac19f5ecc3a}">
           <p14:sldIdLst>
             <p14:sldId id="268"/>
           </p14:sldIdLst>
@@ -1436,7 +1436,7 @@
           <a:p>
             <a:r>
               <a:rPr lang="en-US" dirty="0"/>
-              <a:t>La promesse en une phrase, selon l'exercice de la formation. Elle est en haut du site : « Des bijoux qui ne noircissent pas ».</a:t>
+              <a:t>La promesse en une phrase, sur le modèle « mon produit aide ma cliente à ___, sans ___ ». Elle est en haut du site : « Des bijoux qui ne noircissent pas ».</a:t>
             </a:r>
             <a:endParaRPr lang="en-US" dirty="0"/>
           </a:p>
@@ -1524,7 +1524,7 @@
           <a:p>
             <a:r>
               <a:rPr lang="en-US" dirty="0"/>
-              <a:t>La formation retient un produit s'il remplit au moins 3 critères sur 4. Le collier Marguerite les remplit tous les quatre.</a:t>
+              <a:t>Un produit est retenu s'il remplit au moins 3 critères sur 4. Le collier Marguerite les remplit tous les quatre.</a:t>
             </a:r>
             <a:endParaRPr lang="en-US" dirty="0"/>
           </a:p>
@@ -2235,7 +2235,7 @@
                   <a:schemeClr val="tx2"/>
                 </a:solidFill>
               </a:rPr>
-              <a:t>V A U R E   ·   Projet de boutique, méthode Scutify</a:t>
+              <a:t>V A U R E   ·   Projet de boutique</a:t>
             </a:r>
             <a:endParaRPr lang="en-US" sz="1000" dirty="0"/>
           </a:p>
@@ -2667,7 +2667,7 @@
                   <a:schemeClr val="accent1"/>
                 </a:solidFill>
               </a:rPr>
-              <a:t>PROJET DE BOUTIQUE  ·  MÉTHODE SCUTIFY</a:t>
+              <a:t>PROJET DE BOUTIQUE EN LIGNE</a:t>
             </a:r>
             <a:endParaRPr lang="en-US" sz="1400" dirty="0"/>
           </a:p>
@@ -7356,7 +7356,7 @@
                   <a:schemeClr val="accent4"/>
                 </a:solidFill>
               </a:rPr>
-              <a:t>Exercice Scutify : « Mon produit aide mon client à ___ sans ___ ».</a:t>
+              <a:t>Mon produit aide ma cliente à ___, sans ___.</a:t>
             </a:r>
             <a:endParaRPr lang="en-US" sz="2000" dirty="0"/>
           </a:p>
@@ -7460,7 +7460,7 @@
                 <a:ea typeface="Cambria" pitchFamily="34" charset="-122"/>
                 <a:cs typeface="Cambria" pitchFamily="34" charset="-120"/>
               </a:rPr>
-              <a:t>Les critères Scutify sont remplis</a:t>
+              <a:t>Les 4 critères d'un bon produit</a:t>
             </a:r>
             <a:endParaRPr lang="en-US" sz="3600" dirty="0"/>
           </a:p>
@@ -8152,7 +8152,7 @@
                   <a:schemeClr val="tx2"/>
                 </a:solidFill>
               </a:rPr>
-              <a:t>4 critères sur 4. La formation en demande au moins 3.</a:t>
+              <a:t>4 critères sur 4. Un bon produit en remplit au moins 3.</a:t>
             </a:r>
             <a:endParaRPr lang="en-US" sz="1500" dirty="0"/>
           </a:p>
@@ -9818,7 +9818,7 @@
                   <a:schemeClr val="tx1"/>
                 </a:solidFill>
               </a:rPr>
-              <a:t>Prix fixé à environ 3,7 fois le coût livré (minimum Scutify : 3 fois)</a:t>
+              <a:t>Prix fixé à environ 3,7 fois le coût livré (minimum conseillé : 3 fois)</a:t>
             </a:r>
             <a:endParaRPr lang="en-US" sz="1600" dirty="0"/>
           </a:p>

</xml_diff>

<commit_message>
VAURE : présentation finalisée (typographie française, logo lisible, mises en page équilibrées)
Co-Authored-By: Claude Opus 5.5 <noreply@anthropic.com>
Claude-Session: https://claude.ai/code/session_01E27fDM9kXMS7n6PL6YkZM1
</commit_message>
<xml_diff>
--- a/vaure/presentation/VAURE-presentation.pptx
+++ b/vaure/presentation/VAURE-presentation.pptx
@@ -120,44 +120,44 @@
   <p:extLst>
     <p:ext uri="{521415D9-36F7-43E2-AB2F-B90AF26B5E84}">
       <p14:sectionLst xmlns:p14="http://schemas.microsoft.com/office/powerpoint/2010/main">
-        <p14:section name="Ouverture" id="{0085bd29-2ec6-53c7-cacf-53bc3b947985}">
+        <p14:section name="Ouverture" id="{99512e1b-eb76-e78f-9e43-21cabd81c044}">
           <p14:sldIdLst>
             <p14:sldId id="256"/>
           </p14:sldIdLst>
         </p14:section>
-        <p14:section name="La niche" id="{57f7f67b-b0dc-6a16-20fb-f7273b9500bc}">
+        <p14:section name="La niche" id="{eba1e204-2148-146a-33e9-f02564c3956f}">
           <p14:sldIdLst>
             <p14:sldId id="257"/>
             <p14:sldId id="258"/>
             <p14:sldId id="259"/>
           </p14:sldIdLst>
         </p14:section>
-        <p14:section name="Pourquoi" id="{81d018a2-cc9e-30a8-a389-f2e61a9125dd}">
+        <p14:section name="Pourquoi" id="{04e738b1-462f-c0dc-3672-ab782436b41a}">
           <p14:sldIdLst>
             <p14:sldId id="260"/>
           </p14:sldIdLst>
         </p14:section>
-        <p14:section name="La marque" id="{03111b3c-f37a-b656-dd0a-d96b90324332}">
+        <p14:section name="La marque" id="{f878fbb3-6da1-01b4-cc4a-32c215e69f98}">
           <p14:sldIdLst>
             <p14:sldId id="261"/>
             <p14:sldId id="262"/>
           </p14:sldIdLst>
         </p14:section>
-        <p14:section name="L'offre" id="{5bf65105-9449-ab88-0826-a3a3aa35503a}">
+        <p14:section name="L'offre" id="{475bbd57-c793-8a14-bbc8-d4df08210ff1}">
           <p14:sldIdLst>
             <p14:sldId id="263"/>
             <p14:sldId id="264"/>
             <p14:sldId id="265"/>
           </p14:sldIdLst>
         </p14:section>
-        <p14:section name="Vendre" id="{9490bd39-79b2-4bf9-72f3-1712e4209a72}">
+        <p14:section name="Vendre" id="{ac69c59a-7be9-5d79-9928-f025ca4f4ec6}">
           <p14:sldIdLst>
             <p14:sldId id="266"/>
             <p14:sldId id="267"/>
             <p14:sldId id="268"/>
           </p14:sldIdLst>
         </p14:section>
-        <p14:section name="Clôture" id="{843b542f-23a8-c512-bf13-87d5f7659c62}">
+        <p14:section name="Clôture" id="{db1d8ea8-6e03-1b4f-c759-f069a3dc66b8}">
           <p14:sldIdLst>
             <p14:sldId id="269"/>
           </p14:sldIdLst>
@@ -264,13 +264,13 @@
                 <c:ptCount val="3"/>
                 <c:lvl>
                   <c:pt idx="0">
-                    <c:v>Collier seul (24,90 €)</c:v>
+                    <c:v>Collier seul (24,90 €)</c:v>
                   </c:pt>
                   <c:pt idx="1">
-                    <c:v>Collier + bracelet (38,80 €)</c:v>
+                    <c:v>Collier + bracelet (38,80 €)</c:v>
                   </c:pt>
                   <c:pt idx="2">
-                    <c:v>Parure en écrin (44,90 €)</c:v>
+                    <c:v>Parure en écrin (44,90 €)</c:v>
                   </c:pt>
                 </c:lvl>
               </c:multiLvlStrCache>
@@ -826,7 +826,7 @@
           <a:p>
             <a:r>
               <a:rPr lang="en-US" dirty="0"/>
-              <a:t>Présentation du projet VAURE. Le devoir demandé : dire la niche. La réponse est sur la diapositive suivante.</a:t>
+              <a:t>Présentation du projet VAURE. Le devoir demandé : dire la niche. La réponse est sur la diapositive suivante.</a:t>
             </a:r>
             <a:endParaRPr lang="en-US" dirty="0"/>
           </a:p>
@@ -914,7 +914,7 @@
           <a:p>
             <a:r>
               <a:rPr lang="en-US" dirty="0"/>
-              <a:t>Les chiffres de l'ensemble et de la parure sont des estimations : le coût du bracelet et des puces est à confirmer sur CJ. Objectif : un panier moyen d'au moins 35 €.</a:t>
+              <a:t>Les chiffres de l’ensemble et de la parure sont des estimations : le coût du bracelet et des puces est à confirmer sur CJ. Objectif : un panier moyen d’au moins 35 €.</a:t>
             </a:r>
             <a:endParaRPr lang="en-US" dirty="0"/>
           </a:p>
@@ -1002,7 +1002,7 @@
           <a:p>
             <a:r>
               <a:rPr lang="en-US" dirty="0"/>
-              <a:t>La confiance compte autant que le produit : pas de vocabulaire de site discount, et une urgence qui correspond à une vraie date.</a:t>
+              <a:t>La confiance compte autant que le produit : pas de vocabulaire de site discount, et une urgence qui correspond à une vraie date.</a:t>
             </a:r>
             <a:endParaRPr lang="en-US" dirty="0"/>
           </a:p>
@@ -1090,7 +1090,7 @@
           <a:p>
             <a:r>
               <a:rPr lang="en-US" dirty="0"/>
-              <a:t>Budget total du premier test : environ 150 €, plus environ 20 € d'échantillons.</a:t>
+              <a:t>Budget total du premier test : environ 150 €, plus environ 20 € d’échantillons.</a:t>
             </a:r>
             <a:endParaRPr lang="en-US" dirty="0"/>
           </a:p>
@@ -1266,7 +1266,7 @@
           <a:p>
             <a:r>
               <a:rPr lang="en-US" dirty="0"/>
-              <a:t>Résumé : niche, problème, produit héros, prochaine étape.</a:t>
+              <a:t>Résumé : niche, problème, produit héros, prochaine étape.</a:t>
             </a:r>
             <a:endParaRPr lang="en-US" dirty="0"/>
           </a:p>
@@ -1354,7 +1354,7 @@
           <a:p>
             <a:r>
               <a:rPr lang="en-US" dirty="0"/>
-              <a:t>La niche se dit du plus large au plus précis : marché, catégorie, niche. Ce qui la rend précise : la matière (316L et titane) et le problème réglé (le bijou qui noircit, verdit ou irrite).</a:t>
+              <a:t>La niche se dit du plus large au plus précis : marché, catégorie, niche. Ce qui la rend précise : la matière (316L et titane) et le problème réglé (le bijou qui noircit, verdit ou irrite).</a:t>
             </a:r>
             <a:endParaRPr lang="en-US" dirty="0"/>
           </a:p>
@@ -1442,7 +1442,7 @@
           <a:p>
             <a:r>
               <a:rPr lang="en-US" dirty="0"/>
-              <a:t>La cliente type et ses quatre problèmes. Chaque produit VAURE répond à l'un d'eux.</a:t>
+              <a:t>La cliente type et ses quatre problèmes. Chaque produit VAURE répond à l’un d’eux.</a:t>
             </a:r>
             <a:endParaRPr lang="en-US" dirty="0"/>
           </a:p>
@@ -1530,7 +1530,7 @@
           <a:p>
             <a:r>
               <a:rPr lang="en-US" dirty="0"/>
-              <a:t>La promesse en une phrase. Elle est en haut du site : « Des bijoux qui ne noircissent pas ».</a:t>
+              <a:t>La promesse en une phrase, sur le modèle : mon produit aide ma cliente à…, sans…</a:t>
             </a:r>
             <a:endParaRPr lang="en-US" dirty="0"/>
           </a:p>
@@ -1618,7 +1618,7 @@
           <a:p>
             <a:r>
               <a:rPr lang="en-US" dirty="0"/>
-              <a:t>Un produit est retenu s'il remplit au moins 3 critères sur 4. Le collier Marguerite les remplit tous.</a:t>
+              <a:t>Un produit est retenu s’il remplit au moins 3 critères sur 4. Le collier Marguerite les remplit tous.</a:t>
             </a:r>
             <a:endParaRPr lang="en-US" dirty="0"/>
           </a:p>
@@ -1706,7 +1706,7 @@
           <a:p>
             <a:r>
               <a:rPr lang="en-US" dirty="0"/>
-              <a:t>Pas de symbole ni d'icône : le nom espacé suffit et reste lisible en petit (pied de page, emballage, Instagram).</a:t>
+              <a:t>Pas de symbole ni d’icône : le nom espacé suffit et reste lisible en petit (pied de page, emballage, Instagram).</a:t>
             </a:r>
             <a:endParaRPr lang="en-US" dirty="0"/>
           </a:p>
@@ -1794,7 +1794,7 @@
           <a:p>
             <a:r>
               <a:rPr lang="en-US" dirty="0"/>
-              <a:t>Les deux polices sont des Google Fonts gratuites, utilisées sur le site. Cette présentation utilise Cambria et Calibri pour s'ouvrir correctement sur tous les ordinateurs.</a:t>
+              <a:t>Les deux polices sont des Google Fonts gratuites, utilisées sur le site. Cette présentation utilise Cambria et Calibri pour s’ouvrir correctement sur tous les ordinateurs.</a:t>
             </a:r>
             <a:endParaRPr lang="en-US" dirty="0"/>
           </a:p>
@@ -1882,7 +1882,7 @@
           <a:p>
             <a:r>
               <a:rPr lang="en-US" dirty="0"/>
-              <a:t>Calcul : 24,90 € moins 6,64 € de coût livré et environ 0,75 € de frais de paiement, soit 17,51 €. Avec la TVA, il reste 13,36 €. L'illustration sera remplacée par la photo de l'échantillon.</a:t>
+              <a:t>Calcul, sans TVA : 24,90 € moins 6,64 € de coût livré et environ 0,75 € de frais de paiement, soit 17,51 €. Avec la TVA, il reste 13,36 €. L’illustration sera remplacée par la photo de l’échantillon.</a:t>
             </a:r>
             <a:endParaRPr lang="en-US" dirty="0"/>
           </a:p>
@@ -1970,7 +1970,7 @@
           <a:p>
             <a:r>
               <a:rPr lang="en-US" dirty="0"/>
-              <a:t>Le catalogue de départ reste petit : on ajoutera ce qui se vend.</a:t>
+              <a:t>Le catalogue de départ reste petit : on ajoutera ce qui se vend.</a:t>
             </a:r>
             <a:endParaRPr lang="en-US" dirty="0"/>
           </a:p>
@@ -2301,7 +2301,7 @@
       </p:sp>
       <p:pic>
         <p:nvPicPr>
-          <p:cNvPr id="4" name="Image 0" descr="/tmp/claude-0/-home-user-Jimy/8d8dc964-050b-5d7d-a94e-200167cc2b39/scratchpad/deck/assets/logo-noir.png">    </p:cNvPr>
+          <p:cNvPr id="4" name="Image 0" descr="/tmp/claude-0/-home-user-Jimy/8d8dc964-050b-5d7d-a94e-200167cc2b39/scratchpad/deck/assets/logo-noir-gras.png">    </p:cNvPr>
           <p:cNvPicPr>
             <a:picLocks noChangeAspect="1"/>
           </p:cNvPicPr>
@@ -2315,8 +2315,8 @@
         </p:blipFill>
         <p:spPr>
           <a:xfrm>
-            <a:off x="548640" y="6419088"/>
-            <a:ext cx="1055766" cy="182880"/>
+            <a:off x="548640" y="6382512"/>
+            <a:ext cx="1296546" cy="219456"/>
           </a:xfrm>
           <a:prstGeom prst="rect">
             <a:avLst/>
@@ -2772,7 +2772,7 @@
         <p:spPr>
           <a:xfrm>
             <a:off x="2895448" y="2331720"/>
-            <a:ext cx="6400800" cy="1108748"/>
+            <a:ext cx="6400800" cy="1097343"/>
           </a:xfrm>
           <a:prstGeom prst="rect">
             <a:avLst/>
@@ -3047,7 +3047,7 @@
                   <a:schemeClr val="tx2"/>
                 </a:solidFill>
               </a:rPr>
-              <a:t>La pièce assortie proposée sur la fiche, à un prix d'ensemble</a:t>
+              <a:t>La pièce assortie proposée sur la fiche, à un prix d’ensemble</a:t>
             </a:r>
             <a:endParaRPr lang="en-US" sz="1500" dirty="0"/>
           </a:p>
@@ -3191,7 +3191,7 @@
                   <a:schemeClr val="tx2"/>
                 </a:solidFill>
               </a:rPr>
-              <a:t>3 pièces à 29,90 €, 5 pièces à 44,90 €</a:t>
+              <a:t>3 pièces à 29,90 €, 5 pièces à 44,90 €</a:t>
             </a:r>
             <a:endParaRPr lang="en-US" sz="1500" dirty="0"/>
           </a:p>
@@ -3263,7 +3263,7 @@
                   <a:schemeClr val="tx2"/>
                 </a:solidFill>
               </a:rPr>
-              <a:t>À partir de 35 €</a:t>
+              <a:t>À partir de 35 €</a:t>
             </a:r>
             <a:endParaRPr lang="en-US" sz="1500" dirty="0"/>
           </a:p>
@@ -3427,7 +3427,7 @@
         <p:spPr>
           <a:xfrm>
             <a:off x="548640" y="1691640"/>
-            <a:ext cx="5440680" cy="4480560"/>
+            <a:ext cx="5440680" cy="3840480"/>
           </a:xfrm>
           <a:prstGeom prst="rect">
             <a:avLst/>
@@ -3476,7 +3476,7 @@
                 <a:ea typeface="Cambria" pitchFamily="34" charset="-122"/>
                 <a:cs typeface="Cambria" pitchFamily="34" charset="-120"/>
               </a:rPr>
-              <a:t>L'urgence, toujours vraie</a:t>
+              <a:t>L’urgence, toujours vraie</a:t>
             </a:r>
             <a:endParaRPr lang="en-US" sz="2000" dirty="0"/>
           </a:p>
@@ -3491,7 +3491,7 @@
         <p:spPr>
           <a:xfrm>
             <a:off x="914400" y="2560320"/>
-            <a:ext cx="4754880" cy="3383280"/>
+            <a:ext cx="4754880" cy="2834640"/>
           </a:xfrm>
           <a:prstGeom prst="rect">
             <a:avLst/>
@@ -3516,7 +3516,7 @@
                   <a:schemeClr val="tx1"/>
                 </a:solidFill>
               </a:rPr>
-              <a:t>Noël : « commandez avant le 8 décembre », calculé sur le vrai délai de livraison</a:t>
+              <a:t>Noël : « commandez avant le 8 décembre », calculé sur le vrai délai de livraison</a:t>
             </a:r>
             <a:endParaRPr lang="en-US" sz="1500" dirty="0"/>
           </a:p>
@@ -3552,7 +3552,7 @@
                   <a:schemeClr val="tx1"/>
                 </a:solidFill>
               </a:rPr>
-              <a:t>Fête des mères, Saint-Valentin : de vraies dates</a:t>
+              <a:t>Fête des mères, Saint-Valentin : de vraies dates</a:t>
             </a:r>
             <a:endParaRPr lang="en-US" sz="1500" dirty="0"/>
           </a:p>
@@ -3617,7 +3617,7 @@
                             <a:schemeClr val="bg1"/>
                           </a:solidFill>
                         </a:rPr>
-                        <a:t>On n'écrit pas</a:t>
+                        <a:t>On n’écrit pas</a:t>
                       </a:r>
                       <a:endParaRPr lang="en-US" sz="1500" dirty="0"/>
                     </a:p>
@@ -3865,7 +3865,7 @@
                             <a:schemeClr val="tx1"/>
                           </a:solidFill>
                         </a:rPr>
-                        <a:t>−30 %, vous économisez</a:t>
+                        <a:t>−30 %, vous économisez</a:t>
                       </a:r>
                       <a:endParaRPr lang="en-US" sz="1500" dirty="0"/>
                     </a:p>
@@ -4113,7 +4113,7 @@
                             <a:schemeClr val="tx1"/>
                           </a:solidFill>
                         </a:rPr>
-                        <a:t>Dépêchez-vous !</a:t>
+                        <a:t>Dépêchez-vous !</a:t>
                       </a:r>
                       <a:endParaRPr lang="en-US" sz="1500" dirty="0"/>
                     </a:p>
@@ -4568,7 +4568,7 @@
                   <a:schemeClr val="tx1"/>
                 </a:solidFill>
               </a:rPr>
-              <a:t>« Un bijou doré qui ne noircit pas. »</a:t>
+              <a:t>« Un bijou doré qui ne noircit pas. »</a:t>
             </a:r>
             <a:endParaRPr lang="en-US" sz="1700" dirty="0"/>
           </a:p>
@@ -4604,7 +4604,7 @@
                   <a:schemeClr val="tx2"/>
                 </a:solidFill>
               </a:rPr>
-              <a:t>Le collier porté, puis sous l'eau</a:t>
+              <a:t>Le collier porté, puis sous l’eau</a:t>
             </a:r>
             <a:endParaRPr lang="en-US" sz="1500" dirty="0"/>
           </a:p>
@@ -4679,7 +4679,7 @@
                   <a:schemeClr val="tx1"/>
                 </a:solidFill>
               </a:rPr>
-              <a:t>« 7 jours sous la douche. »</a:t>
+              <a:t>« 7 jours sous la douche. »</a:t>
             </a:r>
             <a:endParaRPr lang="en-US" sz="1700" dirty="0"/>
           </a:p>
@@ -4715,7 +4715,7 @@
                   <a:schemeClr val="tx2"/>
                 </a:solidFill>
               </a:rPr>
-              <a:t>Jour 1, jour 3, jour 7 (si c'est vrai)</a:t>
+              <a:t>Jour 1, jour 3, jour 7 (si c’est vrai)</a:t>
             </a:r>
             <a:endParaRPr lang="en-US" sz="1500" dirty="0"/>
           </a:p>
@@ -4790,7 +4790,7 @@
                   <a:schemeClr val="tx1"/>
                 </a:solidFill>
               </a:rPr>
-              <a:t>« L'allure d'un piercing, sans perçage. »</a:t>
+              <a:t>« L’allure d’un piercing, sans perçage. »</a:t>
             </a:r>
             <a:endParaRPr lang="en-US" sz="1700" dirty="0"/>
           </a:p>
@@ -4826,7 +4826,7 @@
                   <a:schemeClr val="tx2"/>
                 </a:solidFill>
               </a:rPr>
-              <a:t>L'anneau posé en un geste</a:t>
+              <a:t>L’anneau posé en un geste</a:t>
             </a:r>
             <a:endParaRPr lang="en-US" sz="1500" dirty="0"/>
           </a:p>
@@ -4841,7 +4841,7 @@
         <p:spPr>
           <a:xfrm>
             <a:off x="6675120" y="1691640"/>
-            <a:ext cx="4965192" cy="4480560"/>
+            <a:ext cx="4965192" cy="3657600"/>
           </a:xfrm>
           <a:prstGeom prst="rect">
             <a:avLst/>
@@ -4905,7 +4905,7 @@
         <p:spPr>
           <a:xfrm>
             <a:off x="7040880" y="2560320"/>
-            <a:ext cx="4297680" cy="3383280"/>
+            <a:ext cx="4297680" cy="2560320"/>
           </a:xfrm>
           <a:prstGeom prst="rect">
             <a:avLst/>
@@ -4930,7 +4930,7 @@
                   <a:schemeClr val="bg1"/>
                 </a:solidFill>
               </a:rPr>
-              <a:t>3 vidéos × 10 € par jour, pendant 3 à 4 jours</a:t>
+              <a:t>3 vidéos × 10 € par jour, pendant 3 à 4 jours</a:t>
             </a:r>
             <a:endParaRPr lang="en-US" sz="1500" dirty="0"/>
           </a:p>
@@ -4966,7 +4966,7 @@
                   <a:schemeClr val="bg1"/>
                 </a:solidFill>
               </a:rPr>
-              <a:t>On garde : clic &gt; 1,5 %, coût par clic &lt; 0,60 €, coût par achat &lt; 15 €</a:t>
+              <a:t>On garde : clic &gt; 1,5 %, coût par clic &lt; 0,60 €, coût par achat &lt; 15 €</a:t>
             </a:r>
             <a:endParaRPr lang="en-US" sz="1500" dirty="0"/>
           </a:p>
@@ -4984,7 +4984,7 @@
                   <a:schemeClr val="bg1"/>
                 </a:solidFill>
               </a:rPr>
-              <a:t>On coupe une vidéo sans ajout au panier après 25 €</a:t>
+              <a:t>On coupe une vidéo qui n’a aucun ajout au panier après 25 €</a:t>
             </a:r>
             <a:endParaRPr lang="en-US" sz="1500" dirty="0"/>
           </a:p>
@@ -5267,7 +5267,7 @@
                   <a:schemeClr val="tx2"/>
                 </a:solidFill>
               </a:rPr>
-              <a:t>Vérifier VAURE à l'INPI, réserver vaurestudio.com</a:t>
+              <a:t>Vérifier VAURE à l’INPI, réserver vaurestudio.com</a:t>
             </a:r>
             <a:endParaRPr lang="en-US" sz="1400" dirty="0"/>
           </a:p>
@@ -5489,7 +5489,7 @@
                   <a:schemeClr val="tx2"/>
                 </a:solidFill>
               </a:rPr>
-              <a:t>Collier, anneau sans perçage, créoles : test de 7 jours</a:t>
+              <a:t>Collier, anneau sans perçage, créoles : test de 7 jours</a:t>
             </a:r>
             <a:endParaRPr lang="en-US" sz="1400" dirty="0"/>
           </a:p>
@@ -5711,7 +5711,7 @@
                   <a:schemeClr val="tx2"/>
                 </a:solidFill>
               </a:rPr>
-              <a:t>3 vidéos, environ 150 €, décision sur les chiffres</a:t>
+              <a:t>3 vidéos, environ 150 €, décision sur les chiffres</a:t>
             </a:r>
             <a:endParaRPr lang="en-US" sz="1400" dirty="0"/>
           </a:p>
@@ -5725,8 +5725,8 @@
         </p:nvSpPr>
         <p:spPr>
           <a:xfrm>
-            <a:off x="548640" y="5029200"/>
-            <a:ext cx="11091672" cy="1097280"/>
+            <a:off x="548640" y="4663440"/>
+            <a:ext cx="11091672" cy="1005840"/>
           </a:xfrm>
           <a:prstGeom prst="rect">
             <a:avLst/>
@@ -5750,8 +5750,8 @@
         </p:nvSpPr>
         <p:spPr>
           <a:xfrm>
-            <a:off x="914400" y="5029200"/>
-            <a:ext cx="10360152" cy="1097280"/>
+            <a:off x="914400" y="4663440"/>
+            <a:ext cx="10360152" cy="1005840"/>
           </a:xfrm>
           <a:prstGeom prst="rect">
             <a:avLst/>
@@ -5772,7 +5772,7 @@
                   <a:schemeClr val="tx1"/>
                 </a:solidFill>
               </a:rPr>
-              <a:t>Le site de démonstration est prêt : accueil, collections, fiches produit, coffret, panier et pages d'aide, dans l'identité VAURE.</a:t>
+              <a:t>Le site de démonstration est prêt : accueil, collections, fiches produit, coffret, panier et pages d’aide, dans l’identité VAURE.</a:t>
             </a:r>
             <a:endParaRPr lang="en-US" sz="1500" dirty="0"/>
           </a:p>
@@ -5973,7 +5973,7 @@
                   <a:schemeClr val="accent4"/>
                 </a:solidFill>
               </a:rPr>
-              <a:t>Prochaine étape : les échantillons et le premier test.</a:t>
+              <a:t>Prochaine étape : les échantillons et le premier test.</a:t>
             </a:r>
             <a:endParaRPr lang="en-US" sz="2000" dirty="0"/>
           </a:p>
@@ -5995,8 +5995,8 @@
         </p:blipFill>
         <p:spPr>
           <a:xfrm>
-            <a:off x="4907128" y="5897880"/>
-            <a:ext cx="2377440" cy="411821"/>
+            <a:off x="4998568" y="5897880"/>
+            <a:ext cx="2194560" cy="371456"/>
           </a:xfrm>
           <a:prstGeom prst="rect">
             <a:avLst/>
@@ -6535,7 +6535,7 @@
                   <a:schemeClr val="tx2"/>
                 </a:solidFill>
               </a:rPr>
-              <a:t>Bijoux en acier 316L et titane qui ne noircissent pas, de 12,90 à 24,90 €</a:t>
+              <a:t>Bijoux en acier 316L et titane qui ne noircissent pas, de 12,90 à 24,90 €</a:t>
             </a:r>
             <a:endParaRPr lang="en-US" sz="1500" dirty="0"/>
           </a:p>
@@ -6571,7 +6571,7 @@
                   <a:schemeClr val="tx2"/>
                 </a:solidFill>
               </a:rPr>
-              <a:t>Du plus large au plus précis : on ne parle pas à toutes les femmes, mais à celles dont les bijoux ont déjà noirci, verdi ou irrité.</a:t>
+              <a:t>Du plus large au plus précis : on ne parle pas à toutes les femmes, mais à celles dont les bijoux ont déjà noirci, verdi ou irrité.</a:t>
             </a:r>
             <a:endParaRPr lang="en-US" sz="1500" dirty="0"/>
           </a:p>
@@ -6741,11 +6741,11 @@
             <a:avLst/>
           </a:prstGeom>
           <a:solidFill>
-            <a:schemeClr val="bg2"/>
+            <a:schemeClr val="accent5"/>
           </a:solidFill>
           <a:ln w="12700">
             <a:solidFill>
-              <a:schemeClr val="bg2"/>
+              <a:schemeClr val="accent5"/>
             </a:solidFill>
             <a:prstDash val="solid"/>
           </a:ln>
@@ -6884,7 +6884,7 @@
                   <a:schemeClr val="tx1"/>
                 </a:solidFill>
               </a:rPr>
-              <a:t>Budget « coup de cœur » : moins de 30 €</a:t>
+              <a:t>Budget « coup de cœur » : moins de 30 €</a:t>
             </a:r>
             <a:endParaRPr lang="en-US" sz="1500" dirty="0"/>
           </a:p>
@@ -7013,7 +7013,7 @@
                   <a:schemeClr val="tx2"/>
                 </a:solidFill>
               </a:rPr>
-              <a:t>Le collier à 5 € perd sa couleur en deux semaines.</a:t>
+              <a:t>Le collier à 5 € perd sa couleur en deux semaines.</a:t>
             </a:r>
             <a:endParaRPr lang="en-US" sz="1500" dirty="0"/>
           </a:p>
@@ -7124,7 +7124,7 @@
                   <a:schemeClr val="tx2"/>
                 </a:solidFill>
               </a:rPr>
-              <a:t>Ou ils irritent : oreilles, cou, nez.</a:t>
+              <a:t>Ou ils irritent : oreilles, cou, nez.</a:t>
             </a:r>
             <a:endParaRPr lang="en-US" sz="1500" dirty="0"/>
           </a:p>
@@ -7199,7 +7199,7 @@
                   <a:schemeClr val="tx1"/>
                 </a:solidFill>
               </a:rPr>
-              <a:t>Elle n'ose pas se faire percer</a:t>
+              <a:t>Elle n’ose pas se faire percer</a:t>
             </a:r>
             <a:endParaRPr lang="en-US" sz="1800" dirty="0"/>
           </a:p>
@@ -7495,7 +7495,7 @@
                 <a:ea typeface="Cambria" pitchFamily="34" charset="-122"/>
                 <a:cs typeface="Cambria" pitchFamily="34" charset="-120"/>
               </a:rPr>
-              <a:t>« Mon bijou aide ma cliente à briller tous les jours, sans qu'il noircisse ni l'irrite. »</a:t>
+              <a:t>« Mon bijou aide ma cliente à briller tous les jours, sans qu’il noircisse ni l’irrite. »</a:t>
             </a:r>
             <a:endParaRPr lang="en-US" sz="4400" dirty="0"/>
           </a:p>
@@ -7533,7 +7533,7 @@
                   <a:schemeClr val="accent4"/>
                 </a:solidFill>
               </a:rPr>
-              <a:t>Mon produit aide ma cliente à ___, sans ___.</a:t>
+              <a:t>En haut du site, elle devient : « Des bijoux qui ne noircissent pas. »</a:t>
             </a:r>
             <a:endParaRPr lang="en-US" sz="2000" dirty="0"/>
           </a:p>
@@ -7637,7 +7637,7 @@
                 <a:ea typeface="Cambria" pitchFamily="34" charset="-122"/>
                 <a:cs typeface="Cambria" pitchFamily="34" charset="-120"/>
               </a:rPr>
-              <a:t>Les 4 critères d'un bon produit</a:t>
+              <a:t>Les 4 critères d’un bon produit</a:t>
             </a:r>
             <a:endParaRPr lang="en-US" sz="3600" dirty="0"/>
           </a:p>
@@ -8054,7 +8054,7 @@
                   <a:schemeClr val="tx2"/>
                 </a:solidFill>
               </a:rPr>
-              <a:t>Collier Marguerite : 6,64 € livré, vendu 24,90 €, soit 17,51 € avant la pub</a:t>
+              <a:t>Collier Marguerite : 6,64 € livré, vendu 24,90 €, soit 17,51 € avant la pub</a:t>
             </a:r>
             <a:endParaRPr lang="en-US" sz="1500" dirty="0"/>
           </a:p>
@@ -8193,7 +8193,7 @@
                   <a:schemeClr val="tx2"/>
                 </a:solidFill>
               </a:rPr>
-              <a:t>Achat coup de cœur sous 30 €, aucune taille, cadeau toute l'année</a:t>
+              <a:t>Achat coup de cœur sous 30 €, aucune taille, cadeau toute l’année</a:t>
             </a:r>
             <a:endParaRPr lang="en-US" sz="1500" dirty="0"/>
           </a:p>
@@ -8425,8 +8425,8 @@
         </p:blipFill>
         <p:spPr>
           <a:xfrm>
-            <a:off x="1234440" y="3030857"/>
-            <a:ext cx="4069080" cy="704847"/>
+            <a:off x="1234440" y="3034482"/>
+            <a:ext cx="4069080" cy="697596"/>
           </a:xfrm>
           <a:prstGeom prst="rect">
             <a:avLst/>
@@ -8474,8 +8474,8 @@
         </p:blipFill>
         <p:spPr>
           <a:xfrm>
-            <a:off x="6885432" y="3030857"/>
-            <a:ext cx="4069080" cy="704847"/>
+            <a:off x="6885432" y="3034482"/>
+            <a:ext cx="4069080" cy="697596"/>
           </a:xfrm>
           <a:prstGeom prst="rect">
             <a:avLst/>
@@ -8512,7 +8512,7 @@
                   <a:schemeClr val="tx2"/>
                 </a:solidFill>
               </a:rPr>
-              <a:t>Sur fond sombre : ivoire</a:t>
+              <a:t>Sur fond sombre : ivoire</a:t>
             </a:r>
             <a:endParaRPr lang="en-US" sz="1500" dirty="0"/>
           </a:p>
@@ -8548,7 +8548,7 @@
                   <a:schemeClr val="tx2"/>
                 </a:solidFill>
               </a:rPr>
-              <a:t>Sur fond clair : noir encre</a:t>
+              <a:t>Sur fond clair : noir encre</a:t>
             </a:r>
             <a:endParaRPr lang="en-US" sz="1500" dirty="0"/>
           </a:p>
@@ -8584,7 +8584,7 @@
                   <a:schemeClr val="tx1"/>
                 </a:solidFill>
               </a:rPr>
-              <a:t>Le nom seul, en capitales espacées, dans la police Bodoni Moda : simple, lisible dans toutes les langues, et proche des codes de la joaillerie.</a:t>
+              <a:t>Le nom seul, en capitales espacées, dans la police Bodoni Moda : simple, lisible dans toutes les langues, et proche des codes de la joaillerie.</a:t>
             </a:r>
             <a:endParaRPr lang="en-US" sz="1500" dirty="0"/>
           </a:p>
@@ -8914,7 +8914,7 @@
                   <a:schemeClr val="tx1"/>
                 </a:solidFill>
               </a:rPr>
-              <a:t>Manrope : textes, prix et boutons</a:t>
+              <a:t>Manrope : textes, prix et boutons</a:t>
             </a:r>
             <a:endParaRPr lang="en-US" sz="1500" dirty="0"/>
           </a:p>
@@ -9967,7 +9967,7 @@
                 <a:ea typeface="Cambria" pitchFamily="34" charset="-122"/>
                 <a:cs typeface="Cambria" pitchFamily="34" charset="-120"/>
               </a:rPr>
-              <a:t>6,64 €</a:t>
+              <a:t>6,64 €</a:t>
             </a:r>
             <a:endParaRPr lang="en-US" sz="3000" dirty="0"/>
           </a:p>
@@ -10067,7 +10067,7 @@
                 <a:ea typeface="Cambria" pitchFamily="34" charset="-122"/>
                 <a:cs typeface="Cambria" pitchFamily="34" charset="-120"/>
               </a:rPr>
-              <a:t>24,90 €</a:t>
+              <a:t>24,90 €</a:t>
             </a:r>
             <a:endParaRPr lang="en-US" sz="3000" dirty="0"/>
           </a:p>
@@ -10167,7 +10167,7 @@
                 <a:ea typeface="Cambria" pitchFamily="34" charset="-122"/>
                 <a:cs typeface="Cambria" pitchFamily="34" charset="-120"/>
               </a:rPr>
-              <a:t>17,51 €</a:t>
+              <a:t>17,51 €</a:t>
             </a:r>
             <a:endParaRPr lang="en-US" sz="3000" dirty="0"/>
           </a:p>
@@ -10203,7 +10203,7 @@
                   <a:schemeClr val="accent4"/>
                 </a:solidFill>
               </a:rPr>
-              <a:t>reste avant la pub, sans TVA</a:t>
+              <a:t>reste avant la pub</a:t>
             </a:r>
             <a:endParaRPr lang="en-US" sz="1300" dirty="0"/>
           </a:p>
@@ -10261,7 +10261,7 @@
                   <a:schemeClr val="tx1"/>
                 </a:solidFill>
               </a:rPr>
-              <a:t>Fournisseur CJ, réf. CJLX171494501AZ, envoi « Jewel Shipping » suivi</a:t>
+              <a:t>Fournisseur CJ, réf. CJLX171494501AZ, envoi « Jewel Shipping » suivi</a:t>
             </a:r>
             <a:endParaRPr lang="en-US" sz="1500" dirty="0"/>
           </a:p>
@@ -10279,7 +10279,7 @@
                   <a:schemeClr val="tx1"/>
                 </a:solidFill>
               </a:rPr>
-              <a:t>Prix fixé à environ 3,7 fois le coût livré (minimum conseillé : 3 fois)</a:t>
+              <a:t>Prix fixé à environ 3,7 fois le coût livré (minimum conseillé : 3 fois)</a:t>
             </a:r>
             <a:endParaRPr lang="en-US" sz="1500" dirty="0"/>
           </a:p>
@@ -10297,7 +10297,7 @@
                   <a:schemeClr val="tx1"/>
                 </a:solidFill>
               </a:rPr>
-              <a:t>À vérifier : 7 jours sous la douche avec l'échantillon avant d'écrire « résiste à l'eau »</a:t>
+              <a:t>À vérifier : 7 jours sous la douche avec l’échantillon avant d’écrire « résiste à l’eau »</a:t>
             </a:r>
             <a:endParaRPr lang="en-US" sz="1500" dirty="0"/>
           </a:p>
@@ -10788,7 +10788,7 @@
                   <a:schemeClr val="tx1"/>
                 </a:solidFill>
               </a:rPr>
-              <a:t>Produit d'appel</a:t>
+              <a:t>Produit d’appel</a:t>
             </a:r>
             <a:endParaRPr lang="en-US" sz="1300" dirty="0"/>
           </a:p>
@@ -11337,7 +11337,7 @@
                   <a:schemeClr val="tx2"/>
                 </a:solidFill>
               </a:rPr>
-              <a:t>La cohérence vient du style (doré, ivoire, noir), pas du type de produit. Aucun logo de marque ; « plaqué or » et « satiné », jamais « or » ou « soie » sans preuve.</a:t>
+              <a:t>La cohérence vient du style (doré, ivoire, noir), pas du type de produit. Aucun logo de marque ; « plaqué or » et « satiné », jamais « or » ou « soie » sans preuve.</a:t>
             </a:r>
             <a:endParaRPr lang="en-US" sz="1400" dirty="0"/>
           </a:p>

</xml_diff>